<commit_message>
docs: update coding standards to prioritize component reusability
</commit_message>
<xml_diff>
--- a/data/docs/tech/GigLift_Coding_Standards.pptx
+++ b/data/docs/tech/GigLift_Coding_Standards.pptx
@@ -5638,7 +5638,7 @@
               </a:defRPr>
             </a:pPr>
             <a:r>
-              <a:t>NAMING CONVENTIONS</a:t>
+              <a:t>DESIGN FOR REUSE</a:t>
             </a:r>
           </a:p>
         </p:txBody>
@@ -5674,7 +5674,7 @@
               </a:defRPr>
             </a:pPr>
             <a:r>
-              <a:t>• Files: kebab-case (api-client.ts)</a:t>
+              <a:t>• Write code expecting it to be reused later</a:t>
             </a:r>
           </a:p>
         </p:txBody>
@@ -5710,7 +5710,7 @@
               </a:defRPr>
             </a:pPr>
             <a:r>
-              <a:t>• Components: PascalCase (StatCard.tsx)</a:t>
+              <a:t>• Separate business logic (hooks) from UI (JSX)</a:t>
             </a:r>
           </a:p>
         </p:txBody>
@@ -5746,7 +5746,7 @@
               </a:defRPr>
             </a:pPr>
             <a:r>
-              <a:t>• Functions: camelCase (dbGetAllLeads)</a:t>
+              <a:t>• Avoid hardcoding page-specific titles/states</a:t>
             </a:r>
           </a:p>
         </p:txBody>
@@ -5782,7 +5782,7 @@
               </a:defRPr>
             </a:pPr>
             <a:r>
-              <a:t>• Constants: SCREAMING_SNAKE (MAX_PAGE_SIZE)</a:t>
+              <a:t>• Use Generic Types for flexible functions</a:t>
             </a:r>
           </a:p>
         </p:txBody>
@@ -5818,7 +5818,7 @@
               </a:defRPr>
             </a:pPr>
             <a:r>
-              <a:t>• Types/Interfaces: PascalCase (LeadFilters)</a:t>
+              <a:t>• Export constants/config objects from central files</a:t>
             </a:r>
           </a:p>
         </p:txBody>
@@ -5831,7 +5831,7 @@
         </p:nvSpPr>
         <p:spPr>
           <a:xfrm>
-            <a:off x="8275320" y="2816352"/>
+            <a:off x="8275320" y="2889504"/>
             <a:ext cx="3063240" cy="237744"/>
           </a:xfrm>
           <a:prstGeom prst="rect">
@@ -5854,7 +5854,7 @@
               </a:defRPr>
             </a:pPr>
             <a:r>
-              <a:t>• DB functions prefix: db (dbSaveLead)</a:t>
+              <a:t>• Function prefixes:</a:t>
             </a:r>
           </a:p>
         </p:txBody>
@@ -5890,7 +5890,7 @@
               </a:defRPr>
             </a:pPr>
             <a:r>
-              <a:t>• Function prefixes:</a:t>
+              <a:t>  db* — database operations</a:t>
             </a:r>
           </a:p>
         </p:txBody>
@@ -5926,7 +5926,7 @@
               </a:defRPr>
             </a:pPr>
             <a:r>
-              <a:t>  db* — database operations</a:t>
+              <a:t>  fetch* — client API calls</a:t>
             </a:r>
           </a:p>
         </p:txBody>
@@ -5962,7 +5962,7 @@
               </a:defRPr>
             </a:pPr>
             <a:r>
-              <a:t>  fetch* — client API calls</a:t>
+              <a:t>  handle* — event handlers</a:t>
             </a:r>
           </a:p>
         </p:txBody>
@@ -5976,42 +5976,6 @@
         <p:spPr>
           <a:xfrm>
             <a:off x="8275320" y="3767328"/>
-            <a:ext cx="3063240" cy="237744"/>
-          </a:xfrm>
-          <a:prstGeom prst="rect">
-            <a:avLst/>
-          </a:prstGeom>
-          <a:noFill/>
-        </p:spPr>
-        <p:txBody>
-          <a:bodyPr wrap="square">
-            <a:spAutoFit/>
-          </a:bodyPr>
-          <a:lstStyle/>
-          <a:p>
-            <a:pPr algn="l">
-              <a:defRPr sz="1100" b="0">
-                <a:solidFill>
-                  <a:srgbClr val="C8C8DC"/>
-                </a:solidFill>
-                <a:latin typeface="Calibri"/>
-              </a:defRPr>
-            </a:pPr>
-            <a:r>
-              <a:t>  handle* — event handlers</a:t>
-            </a:r>
-          </a:p>
-        </p:txBody>
-      </p:sp>
-      <p:sp>
-        <p:nvSpPr>
-          <p:cNvPr id="43" name="TextBox 42"/>
-          <p:cNvSpPr txBox="1"/>
-          <p:nvPr/>
-        </p:nvSpPr>
-        <p:spPr>
-          <a:xfrm>
-            <a:off x="8275320" y="3986784"/>
             <a:ext cx="3063240" cy="237744"/>
           </a:xfrm>
           <a:prstGeom prst="rect">
@@ -17639,7 +17603,7 @@
               </a:defRPr>
             </a:pPr>
             <a:r>
-              <a:t>COMPONENT STANDARDS</a:t>
+              <a:t>COMPONENT REUSABILITY</a:t>
             </a:r>
           </a:p>
         </p:txBody>
@@ -17675,7 +17639,7 @@
               </a:defRPr>
             </a:pPr>
             <a:r>
-              <a:t>• Max component size: ~300 lines</a:t>
+              <a:t>• Prioritize Reusability across modes/pages</a:t>
             </a:r>
           </a:p>
         </p:txBody>
@@ -17711,7 +17675,7 @@
               </a:defRPr>
             </a:pPr>
             <a:r>
-              <a:t>• Extract reusable UI into src/components/</a:t>
+              <a:t>• Extract shared UI into src/components/</a:t>
             </a:r>
           </a:p>
         </p:txBody>
@@ -17747,7 +17711,7 @@
               </a:defRPr>
             </a:pPr>
             <a:r>
-              <a:t>• Use TypeScript interfaces for all props</a:t>
+              <a:t>• Pass data via props (events, loading, etc.)</a:t>
             </a:r>
           </a:p>
         </p:txBody>
@@ -17783,7 +17747,7 @@
               </a:defRPr>
             </a:pPr>
             <a:r>
-              <a:t>• Export named components (not default) from libs</a:t>
+              <a:t>• Make components props-driven &amp; state-agnostic</a:t>
             </a:r>
           </a:p>
         </p:txBody>
@@ -17855,7 +17819,7 @@
               </a:defRPr>
             </a:pPr>
             <a:r>
-              <a:t>  Components: PascalCase (StatCard.tsx)</a:t>
+              <a:t>  Components: PascalCase (BookingDashboard.tsx)</a:t>
             </a:r>
           </a:p>
         </p:txBody>

</xml_diff>